<commit_message>
Renumber the BADCamp slides to match their order
The deck was reordered in d5b999d but the two-digit label printed on each
slide was not updated, so it no longer tracked the running order: the
PROMETHEUS slide sits at position 12 and read 06, ARCHITECTURE at 7 read
12, and two different slides both read 16.

Rewrite the label on each slide to its position in presentation.xml's
sldIdLst, giving 01..18 with no duplicates. Thirteen slides changed; the
five already correct are untouched.

Only the label text was rewritten. All 85 package entries are preserved,
every XML part still parses, and exactly the thirteen slide parts differ
from the previous file - each slide's kicker text is byte-identical. The
file is ~3K smaller only because rezipping uses different deflate settings
than PowerPoint.

Co-Authored-By: Claude Opus 5 <noreply@anthropic.com>
</commit_message>
<xml_diff>
--- a/presentation/prometheus-badcamp-2026.pptx
+++ b/presentation/prometheus-badcamp-2026.pptx
@@ -2529,7 +2529,7 @@
                 <a:ea typeface="Arial Black" pitchFamily="34" charset="-122"/>
                 <a:cs typeface="Arial Black" pitchFamily="34" charset="-120"/>
               </a:rPr>
-              <a:t>15</a:t>
+              <a:t>10</a:t>
             </a:r>
             <a:endParaRPr lang="en-US" sz="5400" dirty="0"/>
           </a:p>
@@ -4117,7 +4117,7 @@
                 <a:ea typeface="Arial Black" pitchFamily="34" charset="-122"/>
                 <a:cs typeface="Arial Black" pitchFamily="34" charset="-120"/>
               </a:rPr>
-              <a:t>16</a:t>
+              <a:t>11</a:t>
             </a:r>
             <a:endParaRPr lang="en-US" sz="5400" dirty="0"/>
           </a:p>
@@ -4361,7 +4361,7 @@
                 <a:ea typeface="Arial Black" pitchFamily="34" charset="-122"/>
                 <a:cs typeface="Arial Black" pitchFamily="34" charset="-120"/>
               </a:rPr>
-              <a:t>06</a:t>
+              <a:t>12</a:t>
             </a:r>
             <a:endParaRPr lang="en-US" sz="5400" dirty="0"/>
           </a:p>
@@ -4875,7 +4875,7 @@
                 <a:ea typeface="Arial Black" pitchFamily="34" charset="-122"/>
                 <a:cs typeface="Arial Black" pitchFamily="34" charset="-120"/>
               </a:rPr>
-              <a:t>07</a:t>
+              <a:t>13</a:t>
             </a:r>
             <a:endParaRPr lang="en-US" sz="5400" dirty="0"/>
           </a:p>
@@ -5829,7 +5829,7 @@
                 <a:ea typeface="Arial Black" pitchFamily="34" charset="-122"/>
                 <a:cs typeface="Arial Black" pitchFamily="34" charset="-120"/>
               </a:rPr>
-              <a:t>09</a:t>
+              <a:t>14</a:t>
             </a:r>
             <a:endParaRPr lang="en-US" sz="5400" dirty="0"/>
           </a:p>
@@ -6547,7 +6547,7 @@
                 <a:ea typeface="Arial Black" pitchFamily="34" charset="-122"/>
                 <a:cs typeface="Arial Black" pitchFamily="34" charset="-120"/>
               </a:rPr>
-              <a:t>10</a:t>
+              <a:t>15</a:t>
             </a:r>
             <a:endParaRPr lang="en-US" sz="5400" dirty="0"/>
           </a:p>
@@ -7029,7 +7029,7 @@
                 <a:ea typeface="Arial Black" pitchFamily="34" charset="-122"/>
                 <a:cs typeface="Arial Black" pitchFamily="34" charset="-120"/>
               </a:rPr>
-              <a:t>11</a:t>
+              <a:t>16</a:t>
             </a:r>
             <a:endParaRPr lang="en-US" sz="5400" dirty="0"/>
           </a:p>
@@ -7795,7 +7795,7 @@
                 <a:ea typeface="Arial Black" pitchFamily="34" charset="-122"/>
                 <a:cs typeface="Arial Black" pitchFamily="34" charset="-120"/>
               </a:rPr>
-              <a:t>16</a:t>
+              <a:t>17</a:t>
             </a:r>
             <a:endParaRPr lang="en-US" sz="5400" dirty="0"/>
           </a:p>
@@ -8100,7 +8100,7 @@
                 <a:ea typeface="Arial Black" pitchFamily="34" charset="-122"/>
                 <a:cs typeface="Arial Black" pitchFamily="34" charset="-120"/>
               </a:rPr>
-              <a:t>17</a:t>
+              <a:t>18</a:t>
             </a:r>
             <a:endParaRPr lang="en-US" sz="5400" dirty="0"/>
           </a:p>
@@ -10221,7 +10221,7 @@
                 <a:ea typeface="Arial Black" pitchFamily="34" charset="-122"/>
                 <a:cs typeface="Arial Black" pitchFamily="34" charset="-120"/>
               </a:rPr>
-              <a:t>08</a:t>
+              <a:t>06</a:t>
             </a:r>
             <a:endParaRPr lang="en-US" sz="5400" dirty="0"/>
           </a:p>
@@ -10713,7 +10713,7 @@
                 <a:ea typeface="Arial Black" pitchFamily="34" charset="-122"/>
                 <a:cs typeface="Arial Black" pitchFamily="34" charset="-120"/>
               </a:rPr>
-              <a:t>12</a:t>
+              <a:t>07</a:t>
             </a:r>
             <a:endParaRPr lang="en-US" sz="5400" dirty="0"/>
           </a:p>
@@ -11539,7 +11539,7 @@
                 <a:ea typeface="Arial Black" pitchFamily="34" charset="-122"/>
                 <a:cs typeface="Arial Black" pitchFamily="34" charset="-120"/>
               </a:rPr>
-              <a:t>13</a:t>
+              <a:t>08</a:t>
             </a:r>
             <a:endParaRPr lang="en-US" sz="5400" dirty="0"/>
           </a:p>
@@ -12333,7 +12333,7 @@
                 <a:ea typeface="Arial Black" pitchFamily="34" charset="-122"/>
                 <a:cs typeface="Arial Black" pitchFamily="34" charset="-120"/>
               </a:rPr>
-              <a:t>14</a:t>
+              <a:t>09</a:t>
             </a:r>
             <a:endParaRPr lang="en-US" sz="5400" dirty="0"/>
           </a:p>

</xml_diff>

<commit_message>
3rd draft of pptx
</commit_message>
<xml_diff>
--- a/presentation/prometheus-badcamp-2026.pptx
+++ b/presentation/prometheus-badcamp-2026.pptx
@@ -2227,36 +2227,7 @@
               <a:buNone/>
             </a:pPr>
             <a:r>
-              <a:rPr lang="en-US" sz="2000" dirty="0">
-                <a:solidFill>
-                  <a:srgbClr val="0A0A0A"/>
-                </a:solidFill>
-                <a:latin typeface="Arial" pitchFamily="34" charset="0"/>
-                <a:ea typeface="Arial" pitchFamily="34" charset="-122"/>
-                <a:cs typeface="Arial" pitchFamily="34" charset="-120"/>
-              </a:rPr>
-              <a:t>Stealing fire from Pantheon*</a:t>
-            </a:r>
-          </a:p>
-          <a:p>
-            <a:pPr marL="0" indent="0">
-              <a:buNone/>
-            </a:pPr>
-            <a:endParaRPr lang="en-US" sz="2000" dirty="0">
-              <a:solidFill>
-                <a:srgbClr val="0A0A0A"/>
-              </a:solidFill>
-              <a:latin typeface="Arial" pitchFamily="34" charset="0"/>
-              <a:ea typeface="Arial" pitchFamily="34" charset="-122"/>
-              <a:cs typeface="Arial" pitchFamily="34" charset="-120"/>
-            </a:endParaRPr>
-          </a:p>
-          <a:p>
-            <a:pPr marL="0" indent="0">
-              <a:buNone/>
-            </a:pPr>
-            <a:r>
-              <a:rPr lang="en-US" sz="1600" i="1" dirty="0">
+              <a:rPr lang="en-US" sz="1600" dirty="0">
                 <a:solidFill>
                   <a:srgbClr val="0A0A0A"/>
                 </a:solidFill>
@@ -2266,7 +2237,7 @@
               </a:rPr>
               <a:t>Containerized Drupal hosting, so the next PHP security fix takes minutes instead of a day.</a:t>
             </a:r>
-            <a:endParaRPr lang="en-US" sz="1600" i="1" dirty="0"/>
+            <a:endParaRPr lang="en-US" sz="1600" dirty="0"/>
           </a:p>
         </p:txBody>
       </p:sp>
@@ -2306,91 +2277,6 @@
               <a:t>Jordan Koplowicz</a:t>
             </a:r>
             <a:endParaRPr lang="en-US" sz="1600" dirty="0"/>
-          </a:p>
-        </p:txBody>
-      </p:sp>
-      <p:sp>
-        <p:nvSpPr>
-          <p:cNvPr id="10" name="Shape 7">
-            <a:extLst>
-              <a:ext uri="{FF2B5EF4-FFF2-40B4-BE49-F238E27FC236}">
-                <a16:creationId xmlns:a16="http://schemas.microsoft.com/office/drawing/2014/main" id="{29E206F6-700A-6E49-50EA-191284164A48}"/>
-              </a:ext>
-            </a:extLst>
-          </p:cNvPr>
-          <p:cNvSpPr/>
-          <p:nvPr/>
-        </p:nvSpPr>
-        <p:spPr>
-          <a:xfrm>
-            <a:off x="2651760" y="5633720"/>
-            <a:ext cx="64008" cy="731520"/>
-          </a:xfrm>
-          <a:prstGeom prst="rect">
-            <a:avLst/>
-          </a:prstGeom>
-          <a:solidFill>
-            <a:srgbClr val="FF3300"/>
-          </a:solidFill>
-          <a:ln w="12700">
-            <a:solidFill>
-              <a:srgbClr val="FF3300"/>
-            </a:solidFill>
-            <a:prstDash val="solid"/>
-          </a:ln>
-        </p:spPr>
-        <p:txBody>
-          <a:bodyPr/>
-          <a:lstStyle/>
-          <a:p>
-            <a:endParaRPr lang="en-US" sz="1400"/>
-          </a:p>
-        </p:txBody>
-      </p:sp>
-      <p:sp>
-        <p:nvSpPr>
-          <p:cNvPr id="11" name="Text 8">
-            <a:extLst>
-              <a:ext uri="{FF2B5EF4-FFF2-40B4-BE49-F238E27FC236}">
-                <a16:creationId xmlns:a16="http://schemas.microsoft.com/office/drawing/2014/main" id="{41BC4208-C1D7-1C81-35ED-AA5A328494D6}"/>
-              </a:ext>
-            </a:extLst>
-          </p:cNvPr>
-          <p:cNvSpPr/>
-          <p:nvPr/>
-        </p:nvSpPr>
-        <p:spPr>
-          <a:xfrm>
-            <a:off x="2834640" y="5633720"/>
-            <a:ext cx="8869680" cy="731520"/>
-          </a:xfrm>
-          <a:prstGeom prst="rect">
-            <a:avLst/>
-          </a:prstGeom>
-          <a:solidFill>
-            <a:srgbClr val="FFF4F0"/>
-          </a:solidFill>
-          <a:ln/>
-        </p:spPr>
-        <p:txBody>
-          <a:bodyPr wrap="square" lIns="127000" tIns="127000" rIns="127000" bIns="127000" rtlCol="0" anchor="ctr"/>
-          <a:lstStyle/>
-          <a:p>
-            <a:pPr marL="0" indent="0">
-              <a:buNone/>
-            </a:pPr>
-            <a:r>
-              <a:rPr lang="en-US" sz="1400" i="1" dirty="0">
-                <a:solidFill>
-                  <a:srgbClr val="0A0A0A"/>
-                </a:solidFill>
-                <a:latin typeface="Arial" pitchFamily="34" charset="0"/>
-                <a:ea typeface="Arial" pitchFamily="34" charset="-122"/>
-                <a:cs typeface="Arial" pitchFamily="34" charset="-120"/>
-              </a:rPr>
-              <a:t>Disclaimer: I briefly worked for Pantheon in the marketing department.  I never worked on their hosting technology, and I am not privy to their secrets.  This architecture is much simpler and more primitive than what you can get from Pantheon, Acquia, or Platform.sh.</a:t>
-            </a:r>
-            <a:endParaRPr lang="en-US" sz="1400" dirty="0"/>
           </a:p>
         </p:txBody>
       </p:sp>
@@ -4400,7 +4286,7 @@
                 <a:ea typeface="Arial" pitchFamily="34" charset="-122"/>
                 <a:cs typeface="Arial" pitchFamily="34" charset="-120"/>
               </a:rPr>
-              <a:t>THE NEW ARCHITECTURE</a:t>
+              <a:t>Stealing fire from Pantheon*</a:t>
             </a:r>
             <a:endParaRPr lang="en-US" sz="1200" dirty="0"/>
           </a:p>
@@ -4661,14 +4547,20 @@
       </p:sp>
       <p:sp>
         <p:nvSpPr>
-          <p:cNvPr id="9" name="Shape 7"/>
-          <p:cNvSpPr/>
-          <p:nvPr/>
-        </p:nvSpPr>
-        <p:spPr>
-          <a:xfrm>
-            <a:off x="2651760" y="5394960"/>
-            <a:ext cx="64008" cy="822960"/>
+          <p:cNvPr id="11" name="Shape 7">
+            <a:extLst>
+              <a:ext uri="{FF2B5EF4-FFF2-40B4-BE49-F238E27FC236}">
+                <a16:creationId xmlns:a16="http://schemas.microsoft.com/office/drawing/2014/main" id="{4967A09F-8979-36C0-525A-607478CA1A52}"/>
+              </a:ext>
+            </a:extLst>
+          </p:cNvPr>
+          <p:cNvSpPr/>
+          <p:nvPr/>
+        </p:nvSpPr>
+        <p:spPr>
+          <a:xfrm>
+            <a:off x="2651760" y="5633720"/>
+            <a:ext cx="64008" cy="731520"/>
           </a:xfrm>
           <a:prstGeom prst="rect">
             <a:avLst/>
@@ -4687,20 +4579,26 @@
           <a:bodyPr/>
           <a:lstStyle/>
           <a:p>
-            <a:endParaRPr lang="en-US"/>
-          </a:p>
-        </p:txBody>
-      </p:sp>
-      <p:sp>
-        <p:nvSpPr>
-          <p:cNvPr id="10" name="Text 8"/>
-          <p:cNvSpPr/>
-          <p:nvPr/>
-        </p:nvSpPr>
-        <p:spPr>
-          <a:xfrm>
-            <a:off x="2834640" y="5394960"/>
-            <a:ext cx="8869680" cy="822960"/>
+            <a:endParaRPr lang="en-US" sz="1400"/>
+          </a:p>
+        </p:txBody>
+      </p:sp>
+      <p:sp>
+        <p:nvSpPr>
+          <p:cNvPr id="12" name="Text 8">
+            <a:extLst>
+              <a:ext uri="{FF2B5EF4-FFF2-40B4-BE49-F238E27FC236}">
+                <a16:creationId xmlns:a16="http://schemas.microsoft.com/office/drawing/2014/main" id="{DB62221A-160D-51FD-95A9-B72AAD76327B}"/>
+              </a:ext>
+            </a:extLst>
+          </p:cNvPr>
+          <p:cNvSpPr/>
+          <p:nvPr/>
+        </p:nvSpPr>
+        <p:spPr>
+          <a:xfrm>
+            <a:off x="2834640" y="5633720"/>
+            <a:ext cx="8869680" cy="731520"/>
           </a:xfrm>
           <a:prstGeom prst="rect">
             <a:avLst/>
@@ -4718,28 +4616,17 @@
               <a:buNone/>
             </a:pPr>
             <a:r>
-              <a:rPr lang="en-US" sz="1600" i="1" dirty="0">
-                <a:solidFill>
-                  <a:srgbClr val="0A0A0A"/>
-                </a:solidFill>
-                <a:latin typeface="Arial" pitchFamily="34" charset="0"/>
-                <a:ea typeface="Arial" pitchFamily="34" charset="-122"/>
-                <a:cs typeface="Arial" pitchFamily="34" charset="-120"/>
-              </a:rPr>
-              <a:t>Pantheon showed what good Drupal hosting feels like. Prometheus hands that fire to everyone: </a:t>
-            </a:r>
-            <a:r>
-              <a:rPr lang="en-US" sz="1600" b="1" i="1" dirty="0">
-                <a:solidFill>
-                  <a:srgbClr val="0A0A0A"/>
-                </a:solidFill>
-                <a:latin typeface="Arial" pitchFamily="34" charset="0"/>
-                <a:ea typeface="Arial" pitchFamily="34" charset="-122"/>
-                <a:cs typeface="Arial" pitchFamily="34" charset="-120"/>
-              </a:rPr>
-              <a:t>GPL-3.0, self-hosted, one VPS.</a:t>
-            </a:r>
-            <a:endParaRPr lang="en-US" sz="1600" dirty="0"/>
+              <a:rPr lang="en-US" sz="1400" i="1" dirty="0">
+                <a:solidFill>
+                  <a:srgbClr val="0A0A0A"/>
+                </a:solidFill>
+                <a:latin typeface="Arial" pitchFamily="34" charset="0"/>
+                <a:ea typeface="Arial" pitchFamily="34" charset="-122"/>
+                <a:cs typeface="Arial" pitchFamily="34" charset="-120"/>
+              </a:rPr>
+              <a:t>Disclaimer: I briefly worked for Pantheon, in the marketing department.  I never worked on their hosting technology, and I am not privy to their secrets.  This architecture is much simpler and more primitive than what you can get from Pantheon, Acquia, or Platform.sh.</a:t>
+            </a:r>
+            <a:endParaRPr lang="en-US" sz="1400" dirty="0"/>
           </a:p>
         </p:txBody>
       </p:sp>
@@ -7913,9 +7800,6 @@
           <a:bodyPr wrap="square" lIns="127000" tIns="127000" rIns="127000" bIns="127000" rtlCol="0" anchor="ctr"/>
           <a:lstStyle/>
           <a:p>
-            <a:pPr marL="0" indent="0">
-              <a:buNone/>
-            </a:pPr>
             <a:r>
               <a:rPr lang="en-US" sz="1600" i="1" dirty="0">
                 <a:solidFill>
@@ -7925,25 +7809,7 @@
                 <a:ea typeface="Arial" pitchFamily="34" charset="-122"/>
                 <a:cs typeface="Arial" pitchFamily="34" charset="-120"/>
               </a:rPr>
-              <a:t>Live demos </a:t>
-            </a:r>
-            <a:r>
-              <a:rPr lang="en-US" sz="1600" b="1" i="1" u="sng" dirty="0">
-                <a:solidFill>
-                  <a:srgbClr val="FF3300"/>
-                </a:solidFill>
-                <a:latin typeface="Arial" pitchFamily="34" charset="0"/>
-                <a:ea typeface="Arial" pitchFamily="34" charset="-122"/>
-                <a:cs typeface="Arial" pitchFamily="34" charset="-120"/>
-                <a:hlinkClick r:id="rId3">
-                  <a:extLst>
-                    <a:ext uri="{A12FA001-AC4F-418D-AE19-62706E023703}">
-                      <ahyp:hlinkClr xmlns:ahyp="http://schemas.microsoft.com/office/drawing/2018/hyperlinkcolor" val="tx"/>
-                    </a:ext>
-                  </a:extLst>
-                </a:hlinkClick>
-              </a:rPr>
-              <a:t>always work</a:t>
+              <a:t>In case it doesn’t work: </a:t>
             </a:r>
             <a:r>
               <a:rPr lang="en-US" sz="1600" i="1" dirty="0">
@@ -7953,8 +7819,20 @@
                 <a:latin typeface="Arial" pitchFamily="34" charset="0"/>
                 <a:ea typeface="Arial" pitchFamily="34" charset="-122"/>
                 <a:cs typeface="Arial" pitchFamily="34" charset="-120"/>
-              </a:rPr>
-              <a:t> (last year's recording)</a:t>
+                <a:hlinkClick r:id="rId3"/>
+              </a:rPr>
+              <a:t>https://youtu.be/FRIldVYCVGY</a:t>
+            </a:r>
+            <a:r>
+              <a:rPr lang="en-US" sz="1600" i="1" dirty="0">
+                <a:solidFill>
+                  <a:srgbClr val="0A0A0A"/>
+                </a:solidFill>
+                <a:latin typeface="Arial" pitchFamily="34" charset="0"/>
+                <a:ea typeface="Arial" pitchFamily="34" charset="-122"/>
+                <a:cs typeface="Arial" pitchFamily="34" charset="-120"/>
+              </a:rPr>
+              <a:t> </a:t>
             </a:r>
             <a:endParaRPr lang="en-US" sz="1600" dirty="0"/>
           </a:p>
@@ -8663,7 +8541,7 @@
                 <a:ea typeface="Arial Black" pitchFamily="34" charset="-122"/>
                 <a:cs typeface="Arial Black" pitchFamily="34" charset="-120"/>
               </a:rPr>
-              <a:t>The Plan</a:t>
+              <a:t>Outline</a:t>
             </a:r>
             <a:endParaRPr lang="en-US" sz="3600" dirty="0"/>
           </a:p>
@@ -8739,20 +8617,8 @@
                 <a:ea typeface="Arial" pitchFamily="34" charset="-122"/>
                 <a:cs typeface="Arial" pitchFamily="34" charset="-120"/>
               </a:rPr>
-              <a:t>Motivation</a:t>
-            </a:r>
-            <a:r>
-              <a:rPr lang="en-US" sz="2000" dirty="0">
-                <a:solidFill>
-                  <a:srgbClr val="0A0A0A"/>
-                </a:solidFill>
-                <a:latin typeface="Arial" pitchFamily="34" charset="0"/>
-                <a:ea typeface="Arial" pitchFamily="34" charset="-122"/>
-                <a:cs typeface="Arial" pitchFamily="34" charset="-120"/>
-              </a:rPr>
-              <a:t> — the PHP security outage of October 21</a:t>
-            </a:r>
-            <a:endParaRPr lang="en-US" sz="2000" dirty="0"/>
+              <a:t>What is Kubernetes?</a:t>
+            </a:r>
           </a:p>
           <a:p>
             <a:pPr marL="330200" indent="-330200">
@@ -8772,7 +8638,7 @@
                 <a:ea typeface="Arial" pitchFamily="34" charset="-122"/>
                 <a:cs typeface="Arial" pitchFamily="34" charset="-120"/>
               </a:rPr>
-              <a:t>Prometheus</a:t>
+              <a:t>Motivation</a:t>
             </a:r>
             <a:r>
               <a:rPr lang="en-US" sz="2000" dirty="0">
@@ -8783,7 +8649,7 @@
                 <a:ea typeface="Arial" pitchFamily="34" charset="-122"/>
                 <a:cs typeface="Arial" pitchFamily="34" charset="-120"/>
               </a:rPr>
-              <a:t> — the new architecture</a:t>
+              <a:t> — the PHP security outage of October 21</a:t>
             </a:r>
             <a:endParaRPr lang="en-US" sz="2000" dirty="0"/>
           </a:p>
@@ -8797,6 +8663,17 @@
               <a:buAutoNum type="arabicPeriod"/>
             </a:pPr>
             <a:r>
+              <a:rPr lang="en-US" sz="2000" b="1" dirty="0" err="1">
+                <a:solidFill>
+                  <a:srgbClr val="0A0A0A"/>
+                </a:solidFill>
+                <a:latin typeface="Arial" pitchFamily="34" charset="0"/>
+                <a:ea typeface="Arial" pitchFamily="34" charset="-122"/>
+                <a:cs typeface="Arial" pitchFamily="34" charset="-120"/>
+              </a:rPr>
+              <a:t>Dockerfiles</a:t>
+            </a:r>
+            <a:r>
               <a:rPr lang="en-US" sz="2000" b="1" dirty="0">
                 <a:solidFill>
                   <a:srgbClr val="0A0A0A"/>
@@ -8805,7 +8682,7 @@
                 <a:ea typeface="Arial" pitchFamily="34" charset="-122"/>
                 <a:cs typeface="Arial" pitchFamily="34" charset="-120"/>
               </a:rPr>
-              <a:t>Dockerfiles &amp; local dev</a:t>
+              <a:t> &amp; local dev</a:t>
             </a:r>
             <a:r>
               <a:rPr lang="en-US" sz="2000" dirty="0">
@@ -8838,7 +8715,7 @@
                 <a:ea typeface="Arial" pitchFamily="34" charset="-122"/>
                 <a:cs typeface="Arial" pitchFamily="34" charset="-120"/>
               </a:rPr>
-              <a:t>Deploying</a:t>
+              <a:t>Architectural considerations</a:t>
             </a:r>
             <a:r>
               <a:rPr lang="en-US" sz="2000" dirty="0">
@@ -8849,9 +8726,8 @@
                 <a:ea typeface="Arial" pitchFamily="34" charset="-122"/>
                 <a:cs typeface="Arial" pitchFamily="34" charset="-120"/>
               </a:rPr>
-              <a:t> — one bash script: prm</a:t>
-            </a:r>
-            <a:endParaRPr lang="en-US" sz="2000" dirty="0"/>
+              <a:t> — database &amp; persistent storage</a:t>
+            </a:r>
           </a:p>
           <a:p>
             <a:pPr marL="330200" indent="-330200">
@@ -8871,7 +8747,29 @@
                 <a:ea typeface="Arial" pitchFamily="34" charset="-122"/>
                 <a:cs typeface="Arial" pitchFamily="34" charset="-120"/>
               </a:rPr>
-              <a:t>Architectural considerations</a:t>
+              <a:t>Deploying</a:t>
+            </a:r>
+            <a:endParaRPr lang="en-US" sz="2000" dirty="0"/>
+          </a:p>
+          <a:p>
+            <a:pPr marL="330200" indent="-330200">
+              <a:spcAft>
+                <a:spcPts val="1000"/>
+              </a:spcAft>
+              <a:buSzPct val="100000"/>
+              <a:buFont typeface="+mj-lt"/>
+              <a:buAutoNum type="arabicPeriod"/>
+            </a:pPr>
+            <a:r>
+              <a:rPr lang="en-US" sz="2000" b="1" dirty="0">
+                <a:solidFill>
+                  <a:srgbClr val="0A0A0A"/>
+                </a:solidFill>
+                <a:latin typeface="Arial" pitchFamily="34" charset="0"/>
+                <a:ea typeface="Arial" pitchFamily="34" charset="-122"/>
+                <a:cs typeface="Arial" pitchFamily="34" charset="-120"/>
+              </a:rPr>
+              <a:t>Prometheus</a:t>
             </a:r>
             <a:r>
               <a:rPr lang="en-US" sz="2000" dirty="0">
@@ -8882,7 +8780,7 @@
                 <a:ea typeface="Arial" pitchFamily="34" charset="-122"/>
                 <a:cs typeface="Arial" pitchFamily="34" charset="-120"/>
               </a:rPr>
-              <a:t> — database &amp; persistent storage</a:t>
+              <a:t> — the new architecture</a:t>
             </a:r>
             <a:endParaRPr lang="en-US" sz="2000" dirty="0"/>
           </a:p>

</xml_diff>